<commit_message>
Added business impact slide
</commit_message>
<xml_diff>
--- a/SENIOR-CENTER-CYBERSEC-PRESENTATION.pptx
+++ b/SENIOR-CENTER-CYBERSEC-PRESENTATION.pptx
@@ -6,12 +6,13 @@
   </p:sldMasterIdLst>
   <p:sldIdLst>
     <p:sldId id="256" r:id="rId2"/>
-    <p:sldId id="257" r:id="rId3"/>
-    <p:sldId id="262" r:id="rId4"/>
-    <p:sldId id="261" r:id="rId5"/>
-    <p:sldId id="258" r:id="rId6"/>
-    <p:sldId id="259" r:id="rId7"/>
-    <p:sldId id="260" r:id="rId8"/>
+    <p:sldId id="263" r:id="rId3"/>
+    <p:sldId id="257" r:id="rId4"/>
+    <p:sldId id="262" r:id="rId5"/>
+    <p:sldId id="261" r:id="rId6"/>
+    <p:sldId id="258" r:id="rId7"/>
+    <p:sldId id="259" r:id="rId8"/>
+    <p:sldId id="260" r:id="rId9"/>
   </p:sldIdLst>
   <p:sldSz cx="12192000" cy="6858000"/>
   <p:notesSz cx="6858000" cy="9144000"/>
@@ -359,7 +360,7 @@
             <a:fld id="{B61BEF0D-F0BB-DE4B-95CE-6DB70DBA9567}" type="datetimeFigureOut">
               <a:rPr lang="en-US" dirty="0"/>
               <a:pPr/>
-              <a:t>10/1/2026</a:t>
+              <a:t>10/3/2026</a:t>
             </a:fld>
             <a:endParaRPr lang="en-US" dirty="0"/>
           </a:p>
@@ -772,7 +773,7 @@
             <a:fld id="{B61BEF0D-F0BB-DE4B-95CE-6DB70DBA9567}" type="datetimeFigureOut">
               <a:rPr lang="en-US" dirty="0"/>
               <a:pPr/>
-              <a:t>10/1/2026</a:t>
+              <a:t>10/3/2026</a:t>
             </a:fld>
             <a:endParaRPr lang="en-US" dirty="0"/>
           </a:p>
@@ -1047,7 +1048,7 @@
             <a:fld id="{B61BEF0D-F0BB-DE4B-95CE-6DB70DBA9567}" type="datetimeFigureOut">
               <a:rPr lang="en-US" dirty="0"/>
               <a:pPr/>
-              <a:t>10/1/2026</a:t>
+              <a:t>10/3/2026</a:t>
             </a:fld>
             <a:endParaRPr lang="en-US" dirty="0"/>
           </a:p>
@@ -1612,7 +1613,7 @@
             <a:fld id="{B61BEF0D-F0BB-DE4B-95CE-6DB70DBA9567}" type="datetimeFigureOut">
               <a:rPr lang="en-US" dirty="0"/>
               <a:pPr/>
-              <a:t>10/1/2026</a:t>
+              <a:t>10/3/2026</a:t>
             </a:fld>
             <a:endParaRPr lang="en-US" dirty="0"/>
           </a:p>
@@ -1887,7 +1888,7 @@
             <a:fld id="{B61BEF0D-F0BB-DE4B-95CE-6DB70DBA9567}" type="datetimeFigureOut">
               <a:rPr lang="en-US" dirty="0"/>
               <a:pPr/>
-              <a:t>10/1/2026</a:t>
+              <a:t>10/3/2026</a:t>
             </a:fld>
             <a:endParaRPr lang="en-US" dirty="0"/>
           </a:p>
@@ -2446,7 +2447,7 @@
             <a:fld id="{B61BEF0D-F0BB-DE4B-95CE-6DB70DBA9567}" type="datetimeFigureOut">
               <a:rPr lang="en-US" dirty="0"/>
               <a:pPr/>
-              <a:t>10/1/2026</a:t>
+              <a:t>10/3/2026</a:t>
             </a:fld>
             <a:endParaRPr lang="en-US" dirty="0"/>
           </a:p>
@@ -2770,7 +2771,7 @@
             <a:fld id="{B61BEF0D-F0BB-DE4B-95CE-6DB70DBA9567}" type="datetimeFigureOut">
               <a:rPr lang="en-US" dirty="0"/>
               <a:pPr/>
-              <a:t>10/1/2026</a:t>
+              <a:t>10/3/2026</a:t>
             </a:fld>
             <a:endParaRPr lang="en-US" dirty="0"/>
           </a:p>
@@ -2944,7 +2945,7 @@
             <a:fld id="{B61BEF0D-F0BB-DE4B-95CE-6DB70DBA9567}" type="datetimeFigureOut">
               <a:rPr lang="en-US" dirty="0"/>
               <a:pPr/>
-              <a:t>10/1/2026</a:t>
+              <a:t>10/3/2026</a:t>
             </a:fld>
             <a:endParaRPr lang="en-US" dirty="0"/>
           </a:p>
@@ -3179,7 +3180,7 @@
             <a:fld id="{B61BEF0D-F0BB-DE4B-95CE-6DB70DBA9567}" type="datetimeFigureOut">
               <a:rPr lang="en-US" dirty="0"/>
               <a:pPr/>
-              <a:t>10/1/2026</a:t>
+              <a:t>10/3/2026</a:t>
             </a:fld>
             <a:endParaRPr lang="en-US" dirty="0"/>
           </a:p>
@@ -3376,7 +3377,7 @@
             <a:fld id="{B61BEF0D-F0BB-DE4B-95CE-6DB70DBA9567}" type="datetimeFigureOut">
               <a:rPr lang="en-US" dirty="0"/>
               <a:pPr/>
-              <a:t>10/1/2026</a:t>
+              <a:t>10/3/2026</a:t>
             </a:fld>
             <a:endParaRPr lang="en-US" dirty="0"/>
           </a:p>
@@ -3649,7 +3650,7 @@
             <a:fld id="{B61BEF0D-F0BB-DE4B-95CE-6DB70DBA9567}" type="datetimeFigureOut">
               <a:rPr lang="en-US" dirty="0"/>
               <a:pPr/>
-              <a:t>10/1/2026</a:t>
+              <a:t>10/3/2026</a:t>
             </a:fld>
             <a:endParaRPr lang="en-US" dirty="0"/>
           </a:p>
@@ -3912,7 +3913,7 @@
             <a:fld id="{B61BEF0D-F0BB-DE4B-95CE-6DB70DBA9567}" type="datetimeFigureOut">
               <a:rPr lang="en-US" dirty="0"/>
               <a:pPr/>
-              <a:t>10/1/2026</a:t>
+              <a:t>10/3/2026</a:t>
             </a:fld>
             <a:endParaRPr lang="en-US" dirty="0"/>
           </a:p>
@@ -4283,7 +4284,7 @@
             <a:fld id="{B61BEF0D-F0BB-DE4B-95CE-6DB70DBA9567}" type="datetimeFigureOut">
               <a:rPr lang="en-US" dirty="0"/>
               <a:pPr/>
-              <a:t>10/1/2026</a:t>
+              <a:t>10/3/2026</a:t>
             </a:fld>
             <a:endParaRPr lang="en-US" dirty="0"/>
           </a:p>
@@ -4428,7 +4429,7 @@
             <a:fld id="{B61BEF0D-F0BB-DE4B-95CE-6DB70DBA9567}" type="datetimeFigureOut">
               <a:rPr lang="en-US" dirty="0"/>
               <a:pPr/>
-              <a:t>10/1/2026</a:t>
+              <a:t>10/3/2026</a:t>
             </a:fld>
             <a:endParaRPr lang="en-US" dirty="0"/>
           </a:p>
@@ -4550,7 +4551,7 @@
             <a:fld id="{B61BEF0D-F0BB-DE4B-95CE-6DB70DBA9567}" type="datetimeFigureOut">
               <a:rPr lang="en-US" dirty="0"/>
               <a:pPr/>
-              <a:t>10/1/2026</a:t>
+              <a:t>10/3/2026</a:t>
             </a:fld>
             <a:endParaRPr lang="en-US" dirty="0"/>
           </a:p>
@@ -4832,7 +4833,7 @@
             <a:fld id="{B61BEF0D-F0BB-DE4B-95CE-6DB70DBA9567}" type="datetimeFigureOut">
               <a:rPr lang="en-US" dirty="0"/>
               <a:pPr/>
-              <a:t>10/1/2026</a:t>
+              <a:t>10/3/2026</a:t>
             </a:fld>
             <a:endParaRPr lang="en-US" dirty="0"/>
           </a:p>
@@ -5153,7 +5154,7 @@
             <a:fld id="{B61BEF0D-F0BB-DE4B-95CE-6DB70DBA9567}" type="datetimeFigureOut">
               <a:rPr lang="en-US" dirty="0"/>
               <a:pPr/>
-              <a:t>10/1/2026</a:t>
+              <a:t>10/3/2026</a:t>
             </a:fld>
             <a:endParaRPr lang="en-US" dirty="0"/>
           </a:p>
@@ -5364,7 +5365,7 @@
             <a:fld id="{B61BEF0D-F0BB-DE4B-95CE-6DB70DBA9567}" type="datetimeFigureOut">
               <a:rPr lang="en-US" dirty="0"/>
               <a:pPr/>
-              <a:t>10/1/2026</a:t>
+              <a:t>10/3/2026</a:t>
             </a:fld>
             <a:endParaRPr lang="en-US" dirty="0"/>
           </a:p>
@@ -6001,6 +6002,186 @@
           <a:chExt cx="0" cy="0"/>
         </a:xfrm>
       </p:grpSpPr>
+      <p:sp>
+        <p:nvSpPr>
+          <p:cNvPr id="2" name="Title 1">
+            <a:extLst>
+              <a:ext uri="{FF2B5EF4-FFF2-40B4-BE49-F238E27FC236}">
+                <a16:creationId xmlns:a16="http://schemas.microsoft.com/office/drawing/2014/main" id="{88EFC21E-2136-63CA-1084-00C395A3AE19}"/>
+              </a:ext>
+            </a:extLst>
+          </p:cNvPr>
+          <p:cNvSpPr>
+            <a:spLocks noGrp="1"/>
+          </p:cNvSpPr>
+          <p:nvPr>
+            <p:ph type="title"/>
+          </p:nvPr>
+        </p:nvSpPr>
+        <p:spPr>
+          <a:xfrm>
+            <a:off x="685801" y="170330"/>
+            <a:ext cx="10131425" cy="851646"/>
+          </a:xfrm>
+        </p:spPr>
+        <p:txBody>
+          <a:bodyPr/>
+          <a:lstStyle/>
+          <a:p>
+            <a:r>
+              <a:rPr lang="en-US" dirty="0"/>
+              <a:t>Cyber Crime in MA</a:t>
+            </a:r>
+          </a:p>
+        </p:txBody>
+      </p:sp>
+      <p:pic>
+        <p:nvPicPr>
+          <p:cNvPr id="5" name="Picture 4">
+            <a:extLst>
+              <a:ext uri="{FF2B5EF4-FFF2-40B4-BE49-F238E27FC236}">
+                <a16:creationId xmlns:a16="http://schemas.microsoft.com/office/drawing/2014/main" id="{89880643-1AA4-4298-69AA-453A0A42A288}"/>
+              </a:ext>
+            </a:extLst>
+          </p:cNvPr>
+          <p:cNvPicPr>
+            <a:picLocks noChangeAspect="1"/>
+          </p:cNvPicPr>
+          <p:nvPr/>
+        </p:nvPicPr>
+        <p:blipFill>
+          <a:blip r:embed="rId2"/>
+          <a:stretch>
+            <a:fillRect/>
+          </a:stretch>
+        </p:blipFill>
+        <p:spPr>
+          <a:xfrm>
+            <a:off x="2833344" y="903625"/>
+            <a:ext cx="5836337" cy="5622675"/>
+          </a:xfrm>
+          <a:prstGeom prst="rect">
+            <a:avLst/>
+          </a:prstGeom>
+        </p:spPr>
+      </p:pic>
+      <p:sp>
+        <p:nvSpPr>
+          <p:cNvPr id="6" name="Oval 5">
+            <a:extLst>
+              <a:ext uri="{FF2B5EF4-FFF2-40B4-BE49-F238E27FC236}">
+                <a16:creationId xmlns:a16="http://schemas.microsoft.com/office/drawing/2014/main" id="{6EE629EF-4E00-BB2B-33AC-D99890EA9A59}"/>
+              </a:ext>
+            </a:extLst>
+          </p:cNvPr>
+          <p:cNvSpPr/>
+          <p:nvPr/>
+        </p:nvSpPr>
+        <p:spPr>
+          <a:xfrm>
+            <a:off x="6248400" y="4634753"/>
+            <a:ext cx="1658471" cy="887506"/>
+          </a:xfrm>
+          <a:prstGeom prst="ellipse">
+            <a:avLst/>
+          </a:prstGeom>
+          <a:noFill/>
+          <a:ln w="57150">
+            <a:solidFill>
+              <a:srgbClr val="FF0000"/>
+            </a:solidFill>
+          </a:ln>
+        </p:spPr>
+        <p:style>
+          <a:lnRef idx="2">
+            <a:schemeClr val="accent1">
+              <a:shade val="15000"/>
+            </a:schemeClr>
+          </a:lnRef>
+          <a:fillRef idx="1">
+            <a:schemeClr val="accent1"/>
+          </a:fillRef>
+          <a:effectRef idx="0">
+            <a:schemeClr val="accent1"/>
+          </a:effectRef>
+          <a:fontRef idx="minor">
+            <a:schemeClr val="lt1"/>
+          </a:fontRef>
+        </p:style>
+        <p:txBody>
+          <a:bodyPr rtlCol="0" anchor="ctr"/>
+          <a:lstStyle/>
+          <a:p>
+            <a:pPr algn="ctr"/>
+            <a:endParaRPr lang="en-US"/>
+          </a:p>
+        </p:txBody>
+      </p:sp>
+      <p:sp>
+        <p:nvSpPr>
+          <p:cNvPr id="7" name="TextBox 6">
+            <a:extLst>
+              <a:ext uri="{FF2B5EF4-FFF2-40B4-BE49-F238E27FC236}">
+                <a16:creationId xmlns:a16="http://schemas.microsoft.com/office/drawing/2014/main" id="{9BEDD325-3018-4D69-C88F-D9EE02D01937}"/>
+              </a:ext>
+            </a:extLst>
+          </p:cNvPr>
+          <p:cNvSpPr txBox="1"/>
+          <p:nvPr/>
+        </p:nvSpPr>
+        <p:spPr>
+          <a:xfrm>
+            <a:off x="1999130" y="6562166"/>
+            <a:ext cx="7350474" cy="276999"/>
+          </a:xfrm>
+          <a:prstGeom prst="rect">
+            <a:avLst/>
+          </a:prstGeom>
+          <a:noFill/>
+        </p:spPr>
+        <p:txBody>
+          <a:bodyPr wrap="none" rtlCol="0">
+            <a:spAutoFit/>
+          </a:bodyPr>
+          <a:lstStyle/>
+          <a:p>
+            <a:r>
+              <a:rPr lang="en-US" sz="1200" dirty="0"/>
+              <a:t>Source: https://www.linkedin.com/pulse/massachusetts-businesses-lost-137-million-cybercrime-last-aldom-jzwqc/</a:t>
+            </a:r>
+          </a:p>
+        </p:txBody>
+      </p:sp>
+    </p:spTree>
+    <p:extLst>
+      <p:ext uri="{BB962C8B-B14F-4D97-AF65-F5344CB8AC3E}">
+        <p14:creationId xmlns:p14="http://schemas.microsoft.com/office/powerpoint/2010/main" val="2827564161"/>
+      </p:ext>
+    </p:extLst>
+  </p:cSld>
+  <p:clrMapOvr>
+    <a:masterClrMapping/>
+  </p:clrMapOvr>
+</p:sld>
+</file>
+
+<file path=ppt/slides/slide3.xml><?xml version="1.0" encoding="utf-8"?>
+<p:sld xmlns:a="http://schemas.openxmlformats.org/drawingml/2006/main" xmlns:r="http://schemas.openxmlformats.org/officeDocument/2006/relationships" xmlns:p="http://schemas.openxmlformats.org/presentationml/2006/main">
+  <p:cSld>
+    <p:spTree>
+      <p:nvGrpSpPr>
+        <p:cNvPr id="1" name=""/>
+        <p:cNvGrpSpPr/>
+        <p:nvPr/>
+      </p:nvGrpSpPr>
+      <p:grpSpPr>
+        <a:xfrm>
+          <a:off x="0" y="0"/>
+          <a:ext cx="0" cy="0"/>
+          <a:chOff x="0" y="0"/>
+          <a:chExt cx="0" cy="0"/>
+        </a:xfrm>
+      </p:grpSpPr>
       <p:pic>
         <p:nvPicPr>
           <p:cNvPr id="5" name="Picture 4">
@@ -6388,7 +6569,7 @@
 </p:sld>
 </file>
 
-<file path=ppt/slides/slide3.xml><?xml version="1.0" encoding="utf-8"?>
+<file path=ppt/slides/slide4.xml><?xml version="1.0" encoding="utf-8"?>
 <p:sld xmlns:a="http://schemas.openxmlformats.org/drawingml/2006/main" xmlns:r="http://schemas.openxmlformats.org/officeDocument/2006/relationships" xmlns:p="http://schemas.openxmlformats.org/presentationml/2006/main">
   <p:cSld>
     <p:spTree>
@@ -6587,183 +6768,6 @@
 </p:sld>
 </file>
 
-<file path=ppt/slides/slide4.xml><?xml version="1.0" encoding="utf-8"?>
-<p:sld xmlns:a="http://schemas.openxmlformats.org/drawingml/2006/main" xmlns:r="http://schemas.openxmlformats.org/officeDocument/2006/relationships" xmlns:p="http://schemas.openxmlformats.org/presentationml/2006/main">
-  <p:cSld>
-    <p:spTree>
-      <p:nvGrpSpPr>
-        <p:cNvPr id="1" name=""/>
-        <p:cNvGrpSpPr/>
-        <p:nvPr/>
-      </p:nvGrpSpPr>
-      <p:grpSpPr>
-        <a:xfrm>
-          <a:off x="0" y="0"/>
-          <a:ext cx="0" cy="0"/>
-          <a:chOff x="0" y="0"/>
-          <a:chExt cx="0" cy="0"/>
-        </a:xfrm>
-      </p:grpSpPr>
-      <p:sp>
-        <p:nvSpPr>
-          <p:cNvPr id="2" name="Title 1">
-            <a:extLst>
-              <a:ext uri="{FF2B5EF4-FFF2-40B4-BE49-F238E27FC236}">
-                <a16:creationId xmlns:a16="http://schemas.microsoft.com/office/drawing/2014/main" id="{5F26E1D4-512A-6715-CB4C-73140A329456}"/>
-              </a:ext>
-            </a:extLst>
-          </p:cNvPr>
-          <p:cNvSpPr>
-            <a:spLocks noGrp="1"/>
-          </p:cNvSpPr>
-          <p:nvPr>
-            <p:ph type="title"/>
-          </p:nvPr>
-        </p:nvSpPr>
-        <p:spPr/>
-        <p:txBody>
-          <a:bodyPr/>
-          <a:lstStyle/>
-          <a:p>
-            <a:r>
-              <a:rPr lang="en-US" dirty="0"/>
-              <a:t>What about risks at home</a:t>
-            </a:r>
-          </a:p>
-        </p:txBody>
-      </p:sp>
-      <p:sp>
-        <p:nvSpPr>
-          <p:cNvPr id="3" name="Content Placeholder 2">
-            <a:extLst>
-              <a:ext uri="{FF2B5EF4-FFF2-40B4-BE49-F238E27FC236}">
-                <a16:creationId xmlns:a16="http://schemas.microsoft.com/office/drawing/2014/main" id="{8A8A8490-E728-5BDF-5FA5-D128C5494663}"/>
-              </a:ext>
-            </a:extLst>
-          </p:cNvPr>
-          <p:cNvSpPr>
-            <a:spLocks noGrp="1"/>
-          </p:cNvSpPr>
-          <p:nvPr>
-            <p:ph idx="1"/>
-          </p:nvPr>
-        </p:nvSpPr>
-        <p:spPr/>
-        <p:txBody>
-          <a:bodyPr>
-            <a:normAutofit fontScale="62500" lnSpcReduction="20000"/>
-          </a:bodyPr>
-          <a:lstStyle/>
-          <a:p>
-            <a:r>
-              <a:rPr lang="en-US" dirty="0"/>
-              <a:t>Wi-Fi Routers</a:t>
-            </a:r>
-          </a:p>
-          <a:p>
-            <a:r>
-              <a:rPr lang="en-US" dirty="0"/>
-              <a:t>Smart Thermostats</a:t>
-            </a:r>
-          </a:p>
-          <a:p>
-            <a:r>
-              <a:rPr lang="en-US" dirty="0"/>
-              <a:t>Surveillance Cameras</a:t>
-            </a:r>
-          </a:p>
-          <a:p>
-            <a:r>
-              <a:rPr lang="en-US" dirty="0"/>
-              <a:t>Ring Doorbells</a:t>
-            </a:r>
-          </a:p>
-          <a:p>
-            <a:r>
-              <a:rPr lang="en-US" dirty="0"/>
-              <a:t>Home Assistants (i.e. Alexa, Siri,  Google)</a:t>
-            </a:r>
-          </a:p>
-          <a:p>
-            <a:r>
-              <a:rPr lang="en-US" dirty="0"/>
-              <a:t>Smart TV’s</a:t>
-            </a:r>
-          </a:p>
-          <a:p>
-            <a:r>
-              <a:rPr lang="en-US" dirty="0"/>
-              <a:t>Home Computer Use</a:t>
-            </a:r>
-          </a:p>
-          <a:p>
-            <a:pPr lvl="1"/>
-            <a:r>
-              <a:rPr lang="en-US" dirty="0"/>
-              <a:t>Email</a:t>
-            </a:r>
-          </a:p>
-          <a:p>
-            <a:pPr lvl="1"/>
-            <a:r>
-              <a:rPr lang="en-US" dirty="0"/>
-              <a:t>Web Browsing</a:t>
-            </a:r>
-          </a:p>
-          <a:p>
-            <a:r>
-              <a:rPr lang="en-US" dirty="0"/>
-              <a:t>Cell phones (</a:t>
-            </a:r>
-            <a:r>
-              <a:rPr lang="en-US" dirty="0" err="1"/>
-              <a:t>SMSishing</a:t>
-            </a:r>
-            <a:r>
-              <a:rPr lang="en-US" dirty="0"/>
-              <a:t>)</a:t>
-            </a:r>
-          </a:p>
-          <a:p>
-            <a:pPr lvl="1"/>
-            <a:r>
-              <a:rPr lang="en-US" dirty="0"/>
-              <a:t>Bluetooth hacking</a:t>
-            </a:r>
-          </a:p>
-          <a:p>
-            <a:r>
-              <a:rPr lang="en-US" dirty="0"/>
-              <a:t>Visitors using their cell phones on your wi-fi </a:t>
-            </a:r>
-          </a:p>
-          <a:p>
-            <a:r>
-              <a:rPr lang="en-US" dirty="0"/>
-              <a:t>Neighbors within range of your wi-fi</a:t>
-            </a:r>
-          </a:p>
-          <a:p>
-            <a:r>
-              <a:rPr lang="en-US" dirty="0"/>
-              <a:t>Swatting</a:t>
-            </a:r>
-          </a:p>
-        </p:txBody>
-      </p:sp>
-    </p:spTree>
-    <p:extLst>
-      <p:ext uri="{BB962C8B-B14F-4D97-AF65-F5344CB8AC3E}">
-        <p14:creationId xmlns:p14="http://schemas.microsoft.com/office/powerpoint/2010/main" val="3790871912"/>
-      </p:ext>
-    </p:extLst>
-  </p:cSld>
-  <p:clrMapOvr>
-    <a:masterClrMapping/>
-  </p:clrMapOvr>
-</p:sld>
-</file>
-
 <file path=ppt/slides/slide5.xml><?xml version="1.0" encoding="utf-8"?>
 <p:sld xmlns:a="http://schemas.openxmlformats.org/drawingml/2006/main" xmlns:r="http://schemas.openxmlformats.org/officeDocument/2006/relationships" xmlns:p="http://schemas.openxmlformats.org/presentationml/2006/main">
   <p:cSld>
@@ -6786,7 +6790,7 @@
           <p:cNvPr id="2" name="Title 1">
             <a:extLst>
               <a:ext uri="{FF2B5EF4-FFF2-40B4-BE49-F238E27FC236}">
-                <a16:creationId xmlns:a16="http://schemas.microsoft.com/office/drawing/2014/main" id="{0941991E-AD51-DECC-2E3C-9D763F1F3C11}"/>
+                <a16:creationId xmlns:a16="http://schemas.microsoft.com/office/drawing/2014/main" id="{5F26E1D4-512A-6715-CB4C-73140A329456}"/>
               </a:ext>
             </a:extLst>
           </p:cNvPr>
@@ -6804,7 +6808,7 @@
           <a:p>
             <a:r>
               <a:rPr lang="en-US" dirty="0"/>
-              <a:t>What Can you do to protect yourself</a:t>
+              <a:t>What about risks at home</a:t>
             </a:r>
           </a:p>
         </p:txBody>
@@ -6814,7 +6818,7 @@
           <p:cNvPr id="3" name="Content Placeholder 2">
             <a:extLst>
               <a:ext uri="{FF2B5EF4-FFF2-40B4-BE49-F238E27FC236}">
-                <a16:creationId xmlns:a16="http://schemas.microsoft.com/office/drawing/2014/main" id="{362B531D-74F2-4F0F-E942-C83DF665B874}"/>
+                <a16:creationId xmlns:a16="http://schemas.microsoft.com/office/drawing/2014/main" id="{8A8A8490-E728-5BDF-5FA5-D128C5494663}"/>
               </a:ext>
             </a:extLst>
           </p:cNvPr>
@@ -6827,119 +6831,111 @@
         </p:nvSpPr>
         <p:spPr/>
         <p:txBody>
-          <a:bodyPr/>
-          <a:lstStyle/>
-          <a:p>
-            <a:r>
-              <a:rPr lang="en-US" dirty="0"/>
-              <a:t>1. Always ask yourself these 2 questions:</a:t>
+          <a:bodyPr>
+            <a:normAutofit fontScale="62500" lnSpcReduction="20000"/>
+          </a:bodyPr>
+          <a:lstStyle/>
+          <a:p>
+            <a:r>
+              <a:rPr lang="en-US" dirty="0"/>
+              <a:t>Wi-Fi Routers</a:t>
+            </a:r>
+          </a:p>
+          <a:p>
+            <a:r>
+              <a:rPr lang="en-US" dirty="0"/>
+              <a:t>Smart Thermostats</a:t>
+            </a:r>
+          </a:p>
+          <a:p>
+            <a:r>
+              <a:rPr lang="en-US" dirty="0"/>
+              <a:t>Surveillance Cameras</a:t>
+            </a:r>
+          </a:p>
+          <a:p>
+            <a:r>
+              <a:rPr lang="en-US" dirty="0"/>
+              <a:t>Ring Doorbells</a:t>
+            </a:r>
+          </a:p>
+          <a:p>
+            <a:r>
+              <a:rPr lang="en-US" dirty="0"/>
+              <a:t>Home Assistants (i.e. Alexa, Siri,  Google)</a:t>
+            </a:r>
+          </a:p>
+          <a:p>
+            <a:r>
+              <a:rPr lang="en-US" dirty="0"/>
+              <a:t>Smart TV’s</a:t>
+            </a:r>
+          </a:p>
+          <a:p>
+            <a:r>
+              <a:rPr lang="en-US" dirty="0"/>
+              <a:t>Home Computer Use</a:t>
             </a:r>
           </a:p>
           <a:p>
             <a:pPr lvl="1"/>
             <a:r>
               <a:rPr lang="en-US" dirty="0"/>
-              <a:t>Does this involve money?</a:t>
+              <a:t>Email</a:t>
             </a:r>
           </a:p>
           <a:p>
             <a:pPr lvl="1"/>
             <a:r>
               <a:rPr lang="en-US" dirty="0"/>
-              <a:t>Is there a sense of urgency? </a:t>
-            </a:r>
-          </a:p>
-          <a:p>
-            <a:r>
-              <a:rPr lang="en-US" dirty="0"/>
-              <a:t>If you answered yes to any of these</a:t>
+              <a:t>Web Browsing</a:t>
+            </a:r>
+          </a:p>
+          <a:p>
+            <a:r>
+              <a:rPr lang="en-US" dirty="0"/>
+              <a:t>Cell phones (</a:t>
+            </a:r>
+            <a:r>
+              <a:rPr lang="en-US" dirty="0" err="1"/>
+              <a:t>SMSishing</a:t>
+            </a:r>
+            <a:r>
+              <a:rPr lang="en-US" dirty="0"/>
+              <a:t>)</a:t>
             </a:r>
           </a:p>
           <a:p>
             <a:pPr lvl="1"/>
             <a:r>
               <a:rPr lang="en-US" dirty="0"/>
-              <a:t>STOP, this could be a scam</a:t>
-            </a:r>
-          </a:p>
-          <a:p>
-            <a:pPr lvl="1"/>
-            <a:endParaRPr lang="en-US" dirty="0"/>
-          </a:p>
-        </p:txBody>
-      </p:sp>
-      <p:pic>
-        <p:nvPicPr>
-          <p:cNvPr id="5" name="Picture 4">
-            <a:extLst>
-              <a:ext uri="{FF2B5EF4-FFF2-40B4-BE49-F238E27FC236}">
-                <a16:creationId xmlns:a16="http://schemas.microsoft.com/office/drawing/2014/main" id="{0938973C-7033-0ACA-D27D-251AAEC8B0F2}"/>
-              </a:ext>
-            </a:extLst>
-          </p:cNvPr>
-          <p:cNvPicPr>
-            <a:picLocks noChangeAspect="1"/>
-          </p:cNvPicPr>
-          <p:nvPr/>
-        </p:nvPicPr>
-        <p:blipFill>
-          <a:blip r:embed="rId2"/>
-          <a:stretch>
-            <a:fillRect/>
-          </a:stretch>
-        </p:blipFill>
-        <p:spPr>
-          <a:xfrm>
-            <a:off x="7760989" y="1971986"/>
-            <a:ext cx="3056237" cy="3989294"/>
-          </a:xfrm>
-          <a:prstGeom prst="rect">
-            <a:avLst/>
-          </a:prstGeom>
-        </p:spPr>
-      </p:pic>
-      <p:sp>
-        <p:nvSpPr>
-          <p:cNvPr id="6" name="TextBox 5">
-            <a:extLst>
-              <a:ext uri="{FF2B5EF4-FFF2-40B4-BE49-F238E27FC236}">
-                <a16:creationId xmlns:a16="http://schemas.microsoft.com/office/drawing/2014/main" id="{E75FF39E-0494-4562-A47B-BAE3F8343478}"/>
-              </a:ext>
-            </a:extLst>
-          </p:cNvPr>
-          <p:cNvSpPr txBox="1"/>
-          <p:nvPr/>
-        </p:nvSpPr>
-        <p:spPr>
-          <a:xfrm>
-            <a:off x="7001435" y="6248400"/>
-            <a:ext cx="4934364" cy="261610"/>
-          </a:xfrm>
-          <a:prstGeom prst="rect">
-            <a:avLst/>
-          </a:prstGeom>
-          <a:noFill/>
-        </p:spPr>
-        <p:txBody>
-          <a:bodyPr wrap="none" rtlCol="0">
-            <a:spAutoFit/>
-          </a:bodyPr>
-          <a:lstStyle/>
-          <a:p>
-            <a:r>
-              <a:rPr lang="en-US" sz="1100" dirty="0">
-                <a:hlinkClick r:id="rId3"/>
-              </a:rPr>
-              <a:t>https://innovation.consumerreports.org/2026ConsumerCyberReadinessReport.pdf</a:t>
-            </a:r>
-            <a:endParaRPr lang="en-US" sz="1100" dirty="0"/>
+              <a:t>Bluetooth hacking</a:t>
+            </a:r>
+          </a:p>
+          <a:p>
+            <a:r>
+              <a:rPr lang="en-US" dirty="0"/>
+              <a:t>Visitors using their cell phones on your wi-fi </a:t>
+            </a:r>
+          </a:p>
+          <a:p>
+            <a:r>
+              <a:rPr lang="en-US" dirty="0"/>
+              <a:t>Neighbors within range of your wi-fi</a:t>
+            </a:r>
+          </a:p>
+          <a:p>
+            <a:r>
+              <a:rPr lang="en-US" dirty="0"/>
+              <a:t>Swatting</a:t>
+            </a:r>
           </a:p>
         </p:txBody>
       </p:sp>
     </p:spTree>
     <p:extLst>
       <p:ext uri="{BB962C8B-B14F-4D97-AF65-F5344CB8AC3E}">
-        <p14:creationId xmlns:p14="http://schemas.microsoft.com/office/powerpoint/2010/main" val="1437222039"/>
+        <p14:creationId xmlns:p14="http://schemas.microsoft.com/office/powerpoint/2010/main" val="3790871912"/>
       </p:ext>
     </p:extLst>
   </p:cSld>
@@ -6971,6 +6967,191 @@
           <p:cNvPr id="2" name="Title 1">
             <a:extLst>
               <a:ext uri="{FF2B5EF4-FFF2-40B4-BE49-F238E27FC236}">
+                <a16:creationId xmlns:a16="http://schemas.microsoft.com/office/drawing/2014/main" id="{0941991E-AD51-DECC-2E3C-9D763F1F3C11}"/>
+              </a:ext>
+            </a:extLst>
+          </p:cNvPr>
+          <p:cNvSpPr>
+            <a:spLocks noGrp="1"/>
+          </p:cNvSpPr>
+          <p:nvPr>
+            <p:ph type="title"/>
+          </p:nvPr>
+        </p:nvSpPr>
+        <p:spPr/>
+        <p:txBody>
+          <a:bodyPr/>
+          <a:lstStyle/>
+          <a:p>
+            <a:r>
+              <a:rPr lang="en-US" dirty="0"/>
+              <a:t>What Can you do to protect yourself</a:t>
+            </a:r>
+          </a:p>
+        </p:txBody>
+      </p:sp>
+      <p:sp>
+        <p:nvSpPr>
+          <p:cNvPr id="3" name="Content Placeholder 2">
+            <a:extLst>
+              <a:ext uri="{FF2B5EF4-FFF2-40B4-BE49-F238E27FC236}">
+                <a16:creationId xmlns:a16="http://schemas.microsoft.com/office/drawing/2014/main" id="{362B531D-74F2-4F0F-E942-C83DF665B874}"/>
+              </a:ext>
+            </a:extLst>
+          </p:cNvPr>
+          <p:cNvSpPr>
+            <a:spLocks noGrp="1"/>
+          </p:cNvSpPr>
+          <p:nvPr>
+            <p:ph idx="1"/>
+          </p:nvPr>
+        </p:nvSpPr>
+        <p:spPr/>
+        <p:txBody>
+          <a:bodyPr/>
+          <a:lstStyle/>
+          <a:p>
+            <a:r>
+              <a:rPr lang="en-US" dirty="0"/>
+              <a:t>1. Always ask yourself these 2 questions:</a:t>
+            </a:r>
+          </a:p>
+          <a:p>
+            <a:pPr lvl="1"/>
+            <a:r>
+              <a:rPr lang="en-US" dirty="0"/>
+              <a:t>Does this involve money?</a:t>
+            </a:r>
+          </a:p>
+          <a:p>
+            <a:pPr lvl="1"/>
+            <a:r>
+              <a:rPr lang="en-US" dirty="0"/>
+              <a:t>Is there a sense of urgency? </a:t>
+            </a:r>
+          </a:p>
+          <a:p>
+            <a:r>
+              <a:rPr lang="en-US" dirty="0"/>
+              <a:t>If you answered yes to any of these</a:t>
+            </a:r>
+          </a:p>
+          <a:p>
+            <a:pPr lvl="1"/>
+            <a:r>
+              <a:rPr lang="en-US" dirty="0"/>
+              <a:t>STOP, this could be a scam</a:t>
+            </a:r>
+          </a:p>
+          <a:p>
+            <a:pPr lvl="1"/>
+            <a:endParaRPr lang="en-US" dirty="0"/>
+          </a:p>
+        </p:txBody>
+      </p:sp>
+      <p:pic>
+        <p:nvPicPr>
+          <p:cNvPr id="5" name="Picture 4">
+            <a:extLst>
+              <a:ext uri="{FF2B5EF4-FFF2-40B4-BE49-F238E27FC236}">
+                <a16:creationId xmlns:a16="http://schemas.microsoft.com/office/drawing/2014/main" id="{0938973C-7033-0ACA-D27D-251AAEC8B0F2}"/>
+              </a:ext>
+            </a:extLst>
+          </p:cNvPr>
+          <p:cNvPicPr>
+            <a:picLocks noChangeAspect="1"/>
+          </p:cNvPicPr>
+          <p:nvPr/>
+        </p:nvPicPr>
+        <p:blipFill>
+          <a:blip r:embed="rId2"/>
+          <a:stretch>
+            <a:fillRect/>
+          </a:stretch>
+        </p:blipFill>
+        <p:spPr>
+          <a:xfrm>
+            <a:off x="7760989" y="1971986"/>
+            <a:ext cx="3056237" cy="3989294"/>
+          </a:xfrm>
+          <a:prstGeom prst="rect">
+            <a:avLst/>
+          </a:prstGeom>
+        </p:spPr>
+      </p:pic>
+      <p:sp>
+        <p:nvSpPr>
+          <p:cNvPr id="6" name="TextBox 5">
+            <a:extLst>
+              <a:ext uri="{FF2B5EF4-FFF2-40B4-BE49-F238E27FC236}">
+                <a16:creationId xmlns:a16="http://schemas.microsoft.com/office/drawing/2014/main" id="{E75FF39E-0494-4562-A47B-BAE3F8343478}"/>
+              </a:ext>
+            </a:extLst>
+          </p:cNvPr>
+          <p:cNvSpPr txBox="1"/>
+          <p:nvPr/>
+        </p:nvSpPr>
+        <p:spPr>
+          <a:xfrm>
+            <a:off x="7001435" y="6248400"/>
+            <a:ext cx="4934364" cy="261610"/>
+          </a:xfrm>
+          <a:prstGeom prst="rect">
+            <a:avLst/>
+          </a:prstGeom>
+          <a:noFill/>
+        </p:spPr>
+        <p:txBody>
+          <a:bodyPr wrap="none" rtlCol="0">
+            <a:spAutoFit/>
+          </a:bodyPr>
+          <a:lstStyle/>
+          <a:p>
+            <a:r>
+              <a:rPr lang="en-US" sz="1100" dirty="0">
+                <a:hlinkClick r:id="rId3"/>
+              </a:rPr>
+              <a:t>https://innovation.consumerreports.org/2026ConsumerCyberReadinessReport.pdf</a:t>
+            </a:r>
+            <a:endParaRPr lang="en-US" sz="1100" dirty="0"/>
+          </a:p>
+        </p:txBody>
+      </p:sp>
+    </p:spTree>
+    <p:extLst>
+      <p:ext uri="{BB962C8B-B14F-4D97-AF65-F5344CB8AC3E}">
+        <p14:creationId xmlns:p14="http://schemas.microsoft.com/office/powerpoint/2010/main" val="1437222039"/>
+      </p:ext>
+    </p:extLst>
+  </p:cSld>
+  <p:clrMapOvr>
+    <a:masterClrMapping/>
+  </p:clrMapOvr>
+</p:sld>
+</file>
+
+<file path=ppt/slides/slide7.xml><?xml version="1.0" encoding="utf-8"?>
+<p:sld xmlns:a="http://schemas.openxmlformats.org/drawingml/2006/main" xmlns:r="http://schemas.openxmlformats.org/officeDocument/2006/relationships" xmlns:p="http://schemas.openxmlformats.org/presentationml/2006/main">
+  <p:cSld>
+    <p:spTree>
+      <p:nvGrpSpPr>
+        <p:cNvPr id="1" name=""/>
+        <p:cNvGrpSpPr/>
+        <p:nvPr/>
+      </p:nvGrpSpPr>
+      <p:grpSpPr>
+        <a:xfrm>
+          <a:off x="0" y="0"/>
+          <a:ext cx="0" cy="0"/>
+          <a:chOff x="0" y="0"/>
+          <a:chExt cx="0" cy="0"/>
+        </a:xfrm>
+      </p:grpSpPr>
+      <p:sp>
+        <p:nvSpPr>
+          <p:cNvPr id="2" name="Title 1">
+            <a:extLst>
+              <a:ext uri="{FF2B5EF4-FFF2-40B4-BE49-F238E27FC236}">
                 <a16:creationId xmlns:a16="http://schemas.microsoft.com/office/drawing/2014/main" id="{53239663-80B2-DEB2-5F71-475EA2CBE96B}"/>
               </a:ext>
             </a:extLst>
@@ -7153,7 +7334,7 @@
 </p:sld>
 </file>
 
-<file path=ppt/slides/slide7.xml><?xml version="1.0" encoding="utf-8"?>
+<file path=ppt/slides/slide8.xml><?xml version="1.0" encoding="utf-8"?>
 <p:sld xmlns:a="http://schemas.openxmlformats.org/drawingml/2006/main" xmlns:r="http://schemas.openxmlformats.org/officeDocument/2006/relationships" xmlns:p="http://schemas.openxmlformats.org/presentationml/2006/main">
   <p:cSld>
     <p:spTree>

</xml_diff>